<commit_message>
Fill slide 8 alternative design + slide 4 refinements in deck
Co-Authored-By: Claude Opus 4.8 <noreply@anthropic.com>
</commit_message>
<xml_diff>
--- a/docs/COMP6452_Proj2_Task3.pptx
+++ b/docs/COMP6452_Proj2_Task3.pptx
@@ -5356,7 +5356,7 @@
                 </a:solidFill>
                 <a:latin typeface="Calibri"/>
               </a:rPr>
-              <a:t>[TODO — what did the markers say?]</a:t>
+              <a:t>Refinements going into Task 3:</a:t>
             </a:r>
           </a:p>
           <a:p>
@@ -5378,7 +5378,7 @@
                 </a:solidFill>
                 <a:latin typeface="Calibri"/>
               </a:rPr>
-              <a:t>• e.g. scoped domain to chilled/frozen</a:t>
+              <a:t>• scoped domain to chilled / frozen</a:t>
             </a:r>
           </a:p>
           <a:p>
@@ -5389,7 +5389,7 @@
                 </a:solidFill>
                 <a:latin typeface="Calibri"/>
               </a:rPr>
-              <a:t>• e.g. separated FRs / NFRs (RFC 2119</a:t>
+              <a:t>   perishables (hard temp constraint)</a:t>
             </a:r>
           </a:p>
           <a:p>
@@ -5400,7 +5400,7 @@
                 </a:solidFill>
                 <a:latin typeface="Calibri"/>
               </a:rPr>
-              <a:t>   MUST / SHOULD wording)</a:t>
+              <a:t>• requirements rewritten with MUST /</a:t>
             </a:r>
           </a:p>
           <a:p>
@@ -5411,7 +5411,7 @@
                 </a:solidFill>
                 <a:latin typeface="Calibri"/>
               </a:rPr>
-              <a:t>• e.g. role moved from a tx argument</a:t>
+              <a:t>   SHOULD (RFC 2119); FRs vs NFRs split</a:t>
             </a:r>
           </a:p>
           <a:p>
@@ -5422,7 +5422,7 @@
                 </a:solidFill>
                 <a:latin typeface="Calibri"/>
               </a:rPr>
-              <a:t>   to a cryptographic ABAC attribute</a:t>
+              <a:t>• role &amp; oracle rights via ABAC cert</a:t>
             </a:r>
           </a:p>
           <a:p>
@@ -5433,7 +5433,7 @@
                 </a:solidFill>
                 <a:latin typeface="Calibri"/>
               </a:rPr>
-              <a:t>• e.g. added alternative-design</a:t>
+              <a:t>   attributes, not tx arguments</a:t>
             </a:r>
           </a:p>
           <a:p>
@@ -5444,7 +5444,7 @@
                 </a:solidFill>
                 <a:latin typeface="Calibri"/>
               </a:rPr>
-              <a:t>   comparison (centralised DB)</a:t>
+              <a:t>• commercial fields moved to a private</a:t>
             </a:r>
           </a:p>
           <a:p>
@@ -5455,6 +5455,17 @@
                 </a:solidFill>
                 <a:latin typeface="Calibri"/>
               </a:rPr>
+              <a:t>   data collection</a:t>
+            </a:r>
+          </a:p>
+          <a:p>
+            <a:r>
+              <a:rPr sz="1100">
+                <a:solidFill>
+                  <a:srgbClr val="242A30"/>
+                </a:solidFill>
+                <a:latin typeface="Calibri"/>
+              </a:rPr>
               <a:t/>
             </a:r>
           </a:p>
@@ -5466,7 +5477,18 @@
                 </a:solidFill>
                 <a:latin typeface="Calibri"/>
               </a:rPr>
-              <a:t>Fill these with your real feedback.</a:t>
+              <a:t>← confirm against the markers'</a:t>
+            </a:r>
+          </a:p>
+          <a:p>
+            <a:r>
+              <a:rPr sz="1100">
+                <a:solidFill>
+                  <a:srgbClr val="242A30"/>
+                </a:solidFill>
+                <a:latin typeface="Calibri"/>
+              </a:rPr>
+              <a:t>   actual Task 2 feedback</a:t>
             </a:r>
           </a:p>
         </p:txBody>
@@ -6733,7 +6755,7 @@
               </a:spcAft>
             </a:pPr>
             <a:r>
-              <a:rPr sz="1700" b="0">
+              <a:rPr sz="1600" b="0">
                 <a:solidFill>
                   <a:srgbClr val="242A30"/>
                 </a:solidFill>
@@ -6749,7 +6771,7 @@
               </a:spcAft>
             </a:pPr>
             <a:r>
-              <a:rPr sz="1700" b="0">
+              <a:rPr sz="1600" b="0">
                 <a:solidFill>
                   <a:srgbClr val="242A30"/>
                 </a:solidFill>
@@ -6765,7 +6787,7 @@
               </a:spcAft>
             </a:pPr>
             <a:r>
-              <a:rPr sz="1500" b="0">
+              <a:rPr sz="1400" b="0">
                 <a:solidFill>
                   <a:srgbClr val="242A30"/>
                 </a:solidFill>
@@ -6781,7 +6803,7 @@
               </a:spcAft>
             </a:pPr>
             <a:r>
-              <a:rPr sz="1700" b="0">
+              <a:rPr sz="1600" b="0">
                 <a:solidFill>
                   <a:srgbClr val="242A30"/>
                 </a:solidFill>
@@ -6797,7 +6819,7 @@
               </a:spcAft>
             </a:pPr>
             <a:r>
-              <a:rPr sz="1700" b="1">
+              <a:rPr sz="1600" b="1">
                 <a:solidFill>
                   <a:srgbClr val="242A30"/>
                 </a:solidFill>
@@ -6813,7 +6835,7 @@
               </a:spcAft>
             </a:pPr>
             <a:r>
-              <a:rPr sz="1500" b="0">
+              <a:rPr sz="1400" b="0">
                 <a:solidFill>
                   <a:srgbClr val="242A30"/>
                 </a:solidFill>
@@ -6829,7 +6851,7 @@
               </a:spcAft>
             </a:pPr>
             <a:r>
-              <a:rPr sz="1500" b="0">
+              <a:rPr sz="1400" b="0">
                 <a:solidFill>
                   <a:srgbClr val="242A30"/>
                 </a:solidFill>
@@ -6845,13 +6867,13 @@
               </a:spcAft>
             </a:pPr>
             <a:r>
-              <a:rPr sz="1700" b="1">
+              <a:rPr sz="1600" b="1">
                 <a:solidFill>
                   <a:srgbClr val="1C8C8C"/>
                 </a:solidFill>
                 <a:latin typeface="Calibri"/>
               </a:rPr>
-              <a:t>●  Alternative design considered:  [TODO — centralised DB / cloud, and why the</a:t>
+              <a:t>●  Alternative design considered — centralised cloud DB + REST API</a:t>
             </a:r>
           </a:p>
           <a:p>
@@ -6861,13 +6883,77 @@
               </a:spcAft>
             </a:pPr>
             <a:r>
-              <a:rPr sz="1500" b="0">
-                <a:solidFill>
-                  <a:srgbClr val="1C8C8C"/>
-                </a:solidFill>
-                <a:latin typeface="Calibri"/>
-              </a:rPr>
-              <a:t>–  multi-party trust + verifiable automation made blockchain the better fit]</a:t>
+              <a:rPr sz="1400" b="0">
+                <a:solidFill>
+                  <a:srgbClr val="242A30"/>
+                </a:solidFill>
+                <a:latin typeface="Calibri"/>
+              </a:rPr>
+              <a:t>–  one operator owns the record; every other party must trust that operator</a:t>
+            </a:r>
+          </a:p>
+          <a:p>
+            <a:pPr lvl="1">
+              <a:spcAft>
+                <a:spcPts val="700"/>
+              </a:spcAft>
+            </a:pPr>
+            <a:r>
+              <a:rPr sz="1400" b="0">
+                <a:solidFill>
+                  <a:srgbClr val="242A30"/>
+                </a:solidFill>
+                <a:latin typeface="Calibri"/>
+              </a:rPr>
+              <a:t>–  no cryptographically verifiable multi-party automation or shared audit trail</a:t>
+            </a:r>
+          </a:p>
+          <a:p>
+            <a:pPr lvl="1">
+              <a:spcAft>
+                <a:spcPts val="700"/>
+              </a:spcAft>
+            </a:pPr>
+            <a:r>
+              <a:rPr sz="1400" b="0">
+                <a:solidFill>
+                  <a:srgbClr val="242A30"/>
+                </a:solidFill>
+                <a:latin typeface="Calibri"/>
+              </a:rPr>
+              <a:t>–  tamper-evidence &amp; access control rest on one server, not on consensus</a:t>
+            </a:r>
+          </a:p>
+          <a:p>
+            <a:pPr>
+              <a:spcAft>
+                <a:spcPts val="700"/>
+              </a:spcAft>
+            </a:pPr>
+            <a:r>
+              <a:rPr sz="1600" b="1">
+                <a:solidFill>
+                  <a:srgbClr val="2E8B57"/>
+                </a:solidFill>
+                <a:latin typeface="Calibri"/>
+              </a:rPr>
+              <a:t>●  Why blockchain won: verifiable shared state + ABAC + private data, no middleman</a:t>
+            </a:r>
+          </a:p>
+          <a:p>
+            <a:pPr lvl="1">
+              <a:spcAft>
+                <a:spcPts val="700"/>
+              </a:spcAft>
+            </a:pPr>
+            <a:r>
+              <a:rPr sz="1400" b="0">
+                <a:solidFill>
+                  <a:srgbClr val="5B6670"/>
+                </a:solidFill>
+                <a:latin typeface="Calibri"/>
+              </a:rPr>
+              <a:t>–  confirm this matches the alternative you proposed in Task 2</a:t>
             </a:r>
           </a:p>
         </p:txBody>

</xml_diff>